<commit_message>
Make presentation files journal neutral
Signed-off-by: Geunsik Lim <leemgs@gmail.com>
</commit_message>
<xml_diff>
--- a/ppt/orion_en.pptx
+++ b/ppt/orion_en.pptx
@@ -10022,7 +10022,7 @@
                 </a:solidFill>
                 <a:latin typeface="Calibri"/>
               </a:rPr>
-              <a:t>Nature Computational Science</a:t>
+              <a:t>Research Presentation</a:t>
             </a:r>
             <a:endParaRPr lang="en-US" sz="1800" b="0" strike="noStrike" spc="-1" dirty="0">
               <a:solidFill>
@@ -10458,7 +10458,7 @@
                 </a:solidFill>
                 <a:latin typeface="Calibri"/>
               </a:rPr>
-              <a:t>ORION Project  |  Nature Computational Science (under review)</a:t>
+              <a:t>ORION Project</a:t>
             </a:r>
             <a:endParaRPr lang="en-US" sz="1100" b="0" strike="noStrike" spc="-1">
               <a:solidFill>
@@ -11881,7 +11881,7 @@
                 </a:solidFill>
                 <a:latin typeface="Calibri"/>
               </a:rPr>
-              <a:t>ORION Project  |  Nature Computational Science (under review)</a:t>
+              <a:t>ORION Project</a:t>
             </a:r>
             <a:endParaRPr lang="en-US" sz="1100" b="0" strike="noStrike" spc="-1">
               <a:solidFill>
@@ -13986,7 +13986,7 @@
                 </a:solidFill>
                 <a:latin typeface="Calibri"/>
               </a:rPr>
-              <a:t>ORION Project  |  Nature Computational Science (under review)</a:t>
+              <a:t>ORION Project</a:t>
             </a:r>
             <a:endParaRPr lang="en-US" sz="1100" b="0" strike="noStrike" spc="-1">
               <a:solidFill>
@@ -14751,7 +14751,7 @@
                 </a:solidFill>
                 <a:latin typeface="Calibri"/>
               </a:rPr>
-              <a:t>ORION Project  |  Nature Computational Science (under review)</a:t>
+              <a:t>ORION Project</a:t>
             </a:r>
             <a:endParaRPr lang="en-US" sz="1100" b="0" strike="noStrike" spc="-1">
               <a:solidFill>
@@ -16678,7 +16678,7 @@
                 </a:solidFill>
                 <a:latin typeface="Calibri"/>
               </a:rPr>
-              <a:t>ORION Project  |  Nature Computational Science (under review)</a:t>
+              <a:t>ORION Project</a:t>
             </a:r>
             <a:endParaRPr lang="en-US" sz="1100" b="0" strike="noStrike" spc="-1">
               <a:solidFill>
@@ -17561,7 +17561,7 @@
                 </a:solidFill>
                 <a:latin typeface="Calibri"/>
               </a:rPr>
-              <a:t>ORION Project  |  Nature Computational Science (under review)</a:t>
+              <a:t>ORION Project</a:t>
             </a:r>
             <a:endParaRPr lang="en-US" sz="1100" b="0" strike="noStrike" spc="-1">
               <a:solidFill>
@@ -20130,7 +20130,7 @@
                 </a:solidFill>
                 <a:latin typeface="Calibri"/>
               </a:rPr>
-              <a:t>ORION Project  |  Nature Computational Science (under review)</a:t>
+              <a:t>ORION Project</a:t>
             </a:r>
             <a:endParaRPr lang="en-US" sz="1100" b="0" strike="noStrike" spc="-1">
               <a:solidFill>
@@ -22692,7 +22692,7 @@
                 </a:solidFill>
                 <a:latin typeface="Calibri"/>
               </a:rPr>
-              <a:t>ORION Project  |  Nature Computational Science (under review)</a:t>
+              <a:t>ORION Project</a:t>
             </a:r>
             <a:endParaRPr lang="en-US" sz="1100" b="0" strike="noStrike" spc="-1">
               <a:solidFill>
@@ -24593,7 +24593,7 @@
                 </a:solidFill>
                 <a:latin typeface="Calibri"/>
               </a:rPr>
-              <a:t>ORION Project  |  Nature Computational Science (under review)</a:t>
+              <a:t>ORION Project</a:t>
             </a:r>
             <a:endParaRPr lang="en-US" sz="1100" b="0" strike="noStrike" spc="-1">
               <a:solidFill>
@@ -26332,7 +26332,7 @@
                 </a:solidFill>
                 <a:latin typeface="Calibri"/>
               </a:rPr>
-              <a:t>ORION Project  |  Nature Computational Science (under review)</a:t>
+              <a:t>ORION Project</a:t>
             </a:r>
             <a:endParaRPr lang="en-US" sz="1100" b="0" strike="noStrike" spc="-1">
               <a:solidFill>

</xml_diff>